<commit_message>
Show bacon on slide 4; move the toppings close-up to slide 3
Co-Authored-By: Claude Opus 5.5 <noreply@anthropic.com>
Claude-Session: https://claude.ai/code/session_01Dx5RM53PUoT5rpbGiA8PJh
</commit_message>
<xml_diff>
--- a/FiveGuys_Presentation.pptx
+++ b/FiveGuys_Presentation.pptx
@@ -6933,7 +6933,7 @@
         </p:nvPicPr>
         <p:blipFill>
           <a:blip r:embed="rId2"/>
-          <a:srcRect l="3368" r="3368"/>
+          <a:srcRect l="13339" r="13339"/>
           <a:stretch>
             <a:fillRect/>
           </a:stretch>
@@ -8858,7 +8858,7 @@
         </p:nvPicPr>
         <p:blipFill>
           <a:blip r:embed="rId2"/>
-          <a:srcRect l="2261" r="2261"/>
+          <a:srcRect t="8831" b="8831"/>
           <a:stretch>
             <a:fillRect/>
           </a:stretch>

</xml_diff>

<commit_message>
Finish photo-only deck with the photos that downloaded
Slide 2 becomes one full-width open-kitchen photo and slide 5 pairs the
frying photo with the Cajun fries; the potato photo and world map are
dropped because Wikimedia kept rate-limiting those downloads. Slide 4
uses the sharp top-down bacon cheeseburger. Every slide is now real
photos only, with no text.

Co-Authored-By: Claude Opus 5.5 <noreply@anthropic.com>
Claude-Session: https://claude.ai/code/session_01Dx5RM53PUoT5rpbGiA8PJh
</commit_message>
<xml_diff>
--- a/FiveGuys_Presentation.pptx
+++ b/FiveGuys_Presentation.pptx
@@ -5008,7 +5008,7 @@
         </p:nvPicPr>
         <p:blipFill>
           <a:blip r:embed="rId2"/>
-          <a:srcRect r="8530"/>
+          <a:srcRect t="8316" b="24316"/>
           <a:stretch>
             <a:fillRect/>
           </a:stretch>
@@ -5016,7 +5016,7 @@
         <p:spPr>
           <a:xfrm>
             <a:off x="457200" y="411480"/>
-            <a:ext cx="6949440" cy="5674360"/>
+            <a:ext cx="11277600" cy="5674360"/>
           </a:xfrm>
           <a:prstGeom prst="roundRect">
             <a:avLst>
@@ -5025,36 +5025,9 @@
           </a:prstGeom>
         </p:spPr>
       </p:pic>
-      <p:pic>
-        <p:nvPicPr>
-          <p:cNvPr id="3" name="Photo fresh_potatoes_peanuts" descr="Sacks of fresh potatoes and boxes of peanuts inside a Five Guys"/>
-          <p:cNvPicPr>
-            <a:picLocks noChangeAspect="1"/>
-          </p:cNvPicPr>
-          <p:nvPr/>
-        </p:nvPicPr>
-        <p:blipFill>
-          <a:blip r:embed="rId3"/>
-          <a:srcRect l="17982" r="17982"/>
-          <a:stretch>
-            <a:fillRect/>
-          </a:stretch>
-        </p:blipFill>
-        <p:spPr>
-          <a:xfrm>
-            <a:off x="7589520" y="411480"/>
-            <a:ext cx="4145280" cy="5674360"/>
-          </a:xfrm>
-          <a:prstGeom prst="roundRect">
-            <a:avLst>
-              <a:gd name="adj" fmla="val 3088"/>
-            </a:avLst>
-          </a:prstGeom>
-        </p:spPr>
-      </p:pic>
       <p:grpSp>
         <p:nvGrpSpPr>
-          <p:cNvPr id="4" name="Checker band"/>
+          <p:cNvPr id="3" name="Checker band"/>
           <p:cNvGrpSpPr/>
           <p:nvPr/>
         </p:nvGrpSpPr>
@@ -5068,7 +5041,7 @@
         </p:grpSpPr>
         <p:sp>
           <p:nvSpPr>
-            <p:cNvPr id="5" name="Rectangle 4"/>
+            <p:cNvPr id="4" name="Rectangle 3"/>
             <p:cNvSpPr/>
             <p:nvPr/>
           </p:nvSpPr>
@@ -5098,13 +5071,43 @@
         </p:sp>
         <p:sp>
           <p:nvSpPr>
+            <p:cNvPr id="5" name="Rectangle 4"/>
+            <p:cNvSpPr/>
+            <p:nvPr/>
+          </p:nvSpPr>
+          <p:spPr>
+            <a:xfrm>
+              <a:off x="0" y="6451600"/>
+              <a:ext cx="203200" cy="203200"/>
+            </a:xfrm>
+            <a:prstGeom prst="rect">
+              <a:avLst/>
+            </a:prstGeom>
+            <a:solidFill>
+              <a:srgbClr val="ED1C24"/>
+            </a:solidFill>
+            <a:ln>
+              <a:noFill/>
+            </a:ln>
+            <a:effectLst/>
+          </p:spPr>
+          <p:txBody>
+            <a:bodyPr rtlCol="0" anchor="ctr"/>
+            <a:lstStyle/>
+            <a:p>
+              <a:pPr algn="ctr"/>
+            </a:p>
+          </p:txBody>
+        </p:sp>
+        <p:sp>
+          <p:nvSpPr>
             <p:cNvPr id="6" name="Rectangle 5"/>
             <p:cNvSpPr/>
             <p:nvPr/>
           </p:nvSpPr>
           <p:spPr>
             <a:xfrm>
-              <a:off x="0" y="6451600"/>
+              <a:off x="406400" y="6451600"/>
               <a:ext cx="203200" cy="203200"/>
             </a:xfrm>
             <a:prstGeom prst="rect">
@@ -5134,7 +5137,7 @@
           </p:nvSpPr>
           <p:spPr>
             <a:xfrm>
-              <a:off x="406400" y="6451600"/>
+              <a:off x="812800" y="6451600"/>
               <a:ext cx="203200" cy="203200"/>
             </a:xfrm>
             <a:prstGeom prst="rect">
@@ -5164,7 +5167,7 @@
           </p:nvSpPr>
           <p:spPr>
             <a:xfrm>
-              <a:off x="812800" y="6451600"/>
+              <a:off x="1219200" y="6451600"/>
               <a:ext cx="203200" cy="203200"/>
             </a:xfrm>
             <a:prstGeom prst="rect">
@@ -5194,7 +5197,7 @@
           </p:nvSpPr>
           <p:spPr>
             <a:xfrm>
-              <a:off x="1219200" y="6451600"/>
+              <a:off x="1625600" y="6451600"/>
               <a:ext cx="203200" cy="203200"/>
             </a:xfrm>
             <a:prstGeom prst="rect">
@@ -5224,7 +5227,7 @@
           </p:nvSpPr>
           <p:spPr>
             <a:xfrm>
-              <a:off x="1625600" y="6451600"/>
+              <a:off x="2032000" y="6451600"/>
               <a:ext cx="203200" cy="203200"/>
             </a:xfrm>
             <a:prstGeom prst="rect">
@@ -5254,7 +5257,7 @@
           </p:nvSpPr>
           <p:spPr>
             <a:xfrm>
-              <a:off x="2032000" y="6451600"/>
+              <a:off x="2438400" y="6451600"/>
               <a:ext cx="203200" cy="203200"/>
             </a:xfrm>
             <a:prstGeom prst="rect">
@@ -5284,7 +5287,7 @@
           </p:nvSpPr>
           <p:spPr>
             <a:xfrm>
-              <a:off x="2438400" y="6451600"/>
+              <a:off x="2844800" y="6451600"/>
               <a:ext cx="203200" cy="203200"/>
             </a:xfrm>
             <a:prstGeom prst="rect">
@@ -5314,7 +5317,7 @@
           </p:nvSpPr>
           <p:spPr>
             <a:xfrm>
-              <a:off x="2844800" y="6451600"/>
+              <a:off x="3251200" y="6451600"/>
               <a:ext cx="203200" cy="203200"/>
             </a:xfrm>
             <a:prstGeom prst="rect">
@@ -5344,7 +5347,7 @@
           </p:nvSpPr>
           <p:spPr>
             <a:xfrm>
-              <a:off x="3251200" y="6451600"/>
+              <a:off x="3657600" y="6451600"/>
               <a:ext cx="203200" cy="203200"/>
             </a:xfrm>
             <a:prstGeom prst="rect">
@@ -5374,7 +5377,7 @@
           </p:nvSpPr>
           <p:spPr>
             <a:xfrm>
-              <a:off x="3657600" y="6451600"/>
+              <a:off x="4064000" y="6451600"/>
               <a:ext cx="203200" cy="203200"/>
             </a:xfrm>
             <a:prstGeom prst="rect">
@@ -5404,7 +5407,7 @@
           </p:nvSpPr>
           <p:spPr>
             <a:xfrm>
-              <a:off x="4064000" y="6451600"/>
+              <a:off x="4470400" y="6451600"/>
               <a:ext cx="203200" cy="203200"/>
             </a:xfrm>
             <a:prstGeom prst="rect">
@@ -5434,7 +5437,7 @@
           </p:nvSpPr>
           <p:spPr>
             <a:xfrm>
-              <a:off x="4470400" y="6451600"/>
+              <a:off x="4876800" y="6451600"/>
               <a:ext cx="203200" cy="203200"/>
             </a:xfrm>
             <a:prstGeom prst="rect">
@@ -5464,7 +5467,7 @@
           </p:nvSpPr>
           <p:spPr>
             <a:xfrm>
-              <a:off x="4876800" y="6451600"/>
+              <a:off x="5283200" y="6451600"/>
               <a:ext cx="203200" cy="203200"/>
             </a:xfrm>
             <a:prstGeom prst="rect">
@@ -5494,7 +5497,7 @@
           </p:nvSpPr>
           <p:spPr>
             <a:xfrm>
-              <a:off x="5283200" y="6451600"/>
+              <a:off x="5689600" y="6451600"/>
               <a:ext cx="203200" cy="203200"/>
             </a:xfrm>
             <a:prstGeom prst="rect">
@@ -5524,7 +5527,7 @@
           </p:nvSpPr>
           <p:spPr>
             <a:xfrm>
-              <a:off x="5689600" y="6451600"/>
+              <a:off x="6096000" y="6451600"/>
               <a:ext cx="203200" cy="203200"/>
             </a:xfrm>
             <a:prstGeom prst="rect">
@@ -5554,7 +5557,7 @@
           </p:nvSpPr>
           <p:spPr>
             <a:xfrm>
-              <a:off x="6096000" y="6451600"/>
+              <a:off x="6502400" y="6451600"/>
               <a:ext cx="203200" cy="203200"/>
             </a:xfrm>
             <a:prstGeom prst="rect">
@@ -5584,7 +5587,7 @@
           </p:nvSpPr>
           <p:spPr>
             <a:xfrm>
-              <a:off x="6502400" y="6451600"/>
+              <a:off x="6908800" y="6451600"/>
               <a:ext cx="203200" cy="203200"/>
             </a:xfrm>
             <a:prstGeom prst="rect">
@@ -5614,7 +5617,7 @@
           </p:nvSpPr>
           <p:spPr>
             <a:xfrm>
-              <a:off x="6908800" y="6451600"/>
+              <a:off x="7315200" y="6451600"/>
               <a:ext cx="203200" cy="203200"/>
             </a:xfrm>
             <a:prstGeom prst="rect">
@@ -5644,7 +5647,7 @@
           </p:nvSpPr>
           <p:spPr>
             <a:xfrm>
-              <a:off x="7315200" y="6451600"/>
+              <a:off x="7721600" y="6451600"/>
               <a:ext cx="203200" cy="203200"/>
             </a:xfrm>
             <a:prstGeom prst="rect">
@@ -5674,7 +5677,7 @@
           </p:nvSpPr>
           <p:spPr>
             <a:xfrm>
-              <a:off x="7721600" y="6451600"/>
+              <a:off x="8128000" y="6451600"/>
               <a:ext cx="203200" cy="203200"/>
             </a:xfrm>
             <a:prstGeom prst="rect">
@@ -5704,7 +5707,7 @@
           </p:nvSpPr>
           <p:spPr>
             <a:xfrm>
-              <a:off x="8128000" y="6451600"/>
+              <a:off x="8534400" y="6451600"/>
               <a:ext cx="203200" cy="203200"/>
             </a:xfrm>
             <a:prstGeom prst="rect">
@@ -5734,7 +5737,7 @@
           </p:nvSpPr>
           <p:spPr>
             <a:xfrm>
-              <a:off x="8534400" y="6451600"/>
+              <a:off x="8940800" y="6451600"/>
               <a:ext cx="203200" cy="203200"/>
             </a:xfrm>
             <a:prstGeom prst="rect">
@@ -5764,7 +5767,7 @@
           </p:nvSpPr>
           <p:spPr>
             <a:xfrm>
-              <a:off x="8940800" y="6451600"/>
+              <a:off x="9347200" y="6451600"/>
               <a:ext cx="203200" cy="203200"/>
             </a:xfrm>
             <a:prstGeom prst="rect">
@@ -5794,7 +5797,7 @@
           </p:nvSpPr>
           <p:spPr>
             <a:xfrm>
-              <a:off x="9347200" y="6451600"/>
+              <a:off x="9753600" y="6451600"/>
               <a:ext cx="203200" cy="203200"/>
             </a:xfrm>
             <a:prstGeom prst="rect">
@@ -5824,7 +5827,7 @@
           </p:nvSpPr>
           <p:spPr>
             <a:xfrm>
-              <a:off x="9753600" y="6451600"/>
+              <a:off x="10160000" y="6451600"/>
               <a:ext cx="203200" cy="203200"/>
             </a:xfrm>
             <a:prstGeom prst="rect">
@@ -5854,7 +5857,7 @@
           </p:nvSpPr>
           <p:spPr>
             <a:xfrm>
-              <a:off x="10160000" y="6451600"/>
+              <a:off x="10566400" y="6451600"/>
               <a:ext cx="203200" cy="203200"/>
             </a:xfrm>
             <a:prstGeom prst="rect">
@@ -5884,7 +5887,7 @@
           </p:nvSpPr>
           <p:spPr>
             <a:xfrm>
-              <a:off x="10566400" y="6451600"/>
+              <a:off x="10972800" y="6451600"/>
               <a:ext cx="203200" cy="203200"/>
             </a:xfrm>
             <a:prstGeom prst="rect">
@@ -5914,7 +5917,7 @@
           </p:nvSpPr>
           <p:spPr>
             <a:xfrm>
-              <a:off x="10972800" y="6451600"/>
+              <a:off x="11379200" y="6451600"/>
               <a:ext cx="203200" cy="203200"/>
             </a:xfrm>
             <a:prstGeom prst="rect">
@@ -5944,7 +5947,7 @@
           </p:nvSpPr>
           <p:spPr>
             <a:xfrm>
-              <a:off x="11379200" y="6451600"/>
+              <a:off x="11785600" y="6451600"/>
               <a:ext cx="203200" cy="203200"/>
             </a:xfrm>
             <a:prstGeom prst="rect">
@@ -5974,7 +5977,7 @@
           </p:nvSpPr>
           <p:spPr>
             <a:xfrm>
-              <a:off x="11785600" y="6451600"/>
+              <a:off x="203200" y="6654800"/>
               <a:ext cx="203200" cy="203200"/>
             </a:xfrm>
             <a:prstGeom prst="rect">
@@ -6004,7 +6007,7 @@
           </p:nvSpPr>
           <p:spPr>
             <a:xfrm>
-              <a:off x="203200" y="6654800"/>
+              <a:off x="609600" y="6654800"/>
               <a:ext cx="203200" cy="203200"/>
             </a:xfrm>
             <a:prstGeom prst="rect">
@@ -6034,7 +6037,7 @@
           </p:nvSpPr>
           <p:spPr>
             <a:xfrm>
-              <a:off x="609600" y="6654800"/>
+              <a:off x="1016000" y="6654800"/>
               <a:ext cx="203200" cy="203200"/>
             </a:xfrm>
             <a:prstGeom prst="rect">
@@ -6064,7 +6067,7 @@
           </p:nvSpPr>
           <p:spPr>
             <a:xfrm>
-              <a:off x="1016000" y="6654800"/>
+              <a:off x="1422400" y="6654800"/>
               <a:ext cx="203200" cy="203200"/>
             </a:xfrm>
             <a:prstGeom prst="rect">
@@ -6094,7 +6097,7 @@
           </p:nvSpPr>
           <p:spPr>
             <a:xfrm>
-              <a:off x="1422400" y="6654800"/>
+              <a:off x="1828800" y="6654800"/>
               <a:ext cx="203200" cy="203200"/>
             </a:xfrm>
             <a:prstGeom prst="rect">
@@ -6124,7 +6127,7 @@
           </p:nvSpPr>
           <p:spPr>
             <a:xfrm>
-              <a:off x="1828800" y="6654800"/>
+              <a:off x="2235200" y="6654800"/>
               <a:ext cx="203200" cy="203200"/>
             </a:xfrm>
             <a:prstGeom prst="rect">
@@ -6154,7 +6157,7 @@
           </p:nvSpPr>
           <p:spPr>
             <a:xfrm>
-              <a:off x="2235200" y="6654800"/>
+              <a:off x="2641600" y="6654800"/>
               <a:ext cx="203200" cy="203200"/>
             </a:xfrm>
             <a:prstGeom prst="rect">
@@ -6184,7 +6187,7 @@
           </p:nvSpPr>
           <p:spPr>
             <a:xfrm>
-              <a:off x="2641600" y="6654800"/>
+              <a:off x="3048000" y="6654800"/>
               <a:ext cx="203200" cy="203200"/>
             </a:xfrm>
             <a:prstGeom prst="rect">
@@ -6214,7 +6217,7 @@
           </p:nvSpPr>
           <p:spPr>
             <a:xfrm>
-              <a:off x="3048000" y="6654800"/>
+              <a:off x="3454400" y="6654800"/>
               <a:ext cx="203200" cy="203200"/>
             </a:xfrm>
             <a:prstGeom prst="rect">
@@ -6244,7 +6247,7 @@
           </p:nvSpPr>
           <p:spPr>
             <a:xfrm>
-              <a:off x="3454400" y="6654800"/>
+              <a:off x="3860800" y="6654800"/>
               <a:ext cx="203200" cy="203200"/>
             </a:xfrm>
             <a:prstGeom prst="rect">
@@ -6274,7 +6277,7 @@
           </p:nvSpPr>
           <p:spPr>
             <a:xfrm>
-              <a:off x="3860800" y="6654800"/>
+              <a:off x="4267200" y="6654800"/>
               <a:ext cx="203200" cy="203200"/>
             </a:xfrm>
             <a:prstGeom prst="rect">
@@ -6304,7 +6307,7 @@
           </p:nvSpPr>
           <p:spPr>
             <a:xfrm>
-              <a:off x="4267200" y="6654800"/>
+              <a:off x="4673600" y="6654800"/>
               <a:ext cx="203200" cy="203200"/>
             </a:xfrm>
             <a:prstGeom prst="rect">
@@ -6334,7 +6337,7 @@
           </p:nvSpPr>
           <p:spPr>
             <a:xfrm>
-              <a:off x="4673600" y="6654800"/>
+              <a:off x="5080000" y="6654800"/>
               <a:ext cx="203200" cy="203200"/>
             </a:xfrm>
             <a:prstGeom prst="rect">
@@ -6364,7 +6367,7 @@
           </p:nvSpPr>
           <p:spPr>
             <a:xfrm>
-              <a:off x="5080000" y="6654800"/>
+              <a:off x="5486400" y="6654800"/>
               <a:ext cx="203200" cy="203200"/>
             </a:xfrm>
             <a:prstGeom prst="rect">
@@ -6394,7 +6397,7 @@
           </p:nvSpPr>
           <p:spPr>
             <a:xfrm>
-              <a:off x="5486400" y="6654800"/>
+              <a:off x="5892800" y="6654800"/>
               <a:ext cx="203200" cy="203200"/>
             </a:xfrm>
             <a:prstGeom prst="rect">
@@ -6424,7 +6427,7 @@
           </p:nvSpPr>
           <p:spPr>
             <a:xfrm>
-              <a:off x="5892800" y="6654800"/>
+              <a:off x="6299200" y="6654800"/>
               <a:ext cx="203200" cy="203200"/>
             </a:xfrm>
             <a:prstGeom prst="rect">
@@ -6454,7 +6457,7 @@
           </p:nvSpPr>
           <p:spPr>
             <a:xfrm>
-              <a:off x="6299200" y="6654800"/>
+              <a:off x="6705600" y="6654800"/>
               <a:ext cx="203200" cy="203200"/>
             </a:xfrm>
             <a:prstGeom prst="rect">
@@ -6484,7 +6487,7 @@
           </p:nvSpPr>
           <p:spPr>
             <a:xfrm>
-              <a:off x="6705600" y="6654800"/>
+              <a:off x="7112000" y="6654800"/>
               <a:ext cx="203200" cy="203200"/>
             </a:xfrm>
             <a:prstGeom prst="rect">
@@ -6514,7 +6517,7 @@
           </p:nvSpPr>
           <p:spPr>
             <a:xfrm>
-              <a:off x="7112000" y="6654800"/>
+              <a:off x="7518400" y="6654800"/>
               <a:ext cx="203200" cy="203200"/>
             </a:xfrm>
             <a:prstGeom prst="rect">
@@ -6544,7 +6547,7 @@
           </p:nvSpPr>
           <p:spPr>
             <a:xfrm>
-              <a:off x="7518400" y="6654800"/>
+              <a:off x="7924800" y="6654800"/>
               <a:ext cx="203200" cy="203200"/>
             </a:xfrm>
             <a:prstGeom prst="rect">
@@ -6574,7 +6577,7 @@
           </p:nvSpPr>
           <p:spPr>
             <a:xfrm>
-              <a:off x="7924800" y="6654800"/>
+              <a:off x="8331200" y="6654800"/>
               <a:ext cx="203200" cy="203200"/>
             </a:xfrm>
             <a:prstGeom prst="rect">
@@ -6604,7 +6607,7 @@
           </p:nvSpPr>
           <p:spPr>
             <a:xfrm>
-              <a:off x="8331200" y="6654800"/>
+              <a:off x="8737600" y="6654800"/>
               <a:ext cx="203200" cy="203200"/>
             </a:xfrm>
             <a:prstGeom prst="rect">
@@ -6634,7 +6637,7 @@
           </p:nvSpPr>
           <p:spPr>
             <a:xfrm>
-              <a:off x="8737600" y="6654800"/>
+              <a:off x="9144000" y="6654800"/>
               <a:ext cx="203200" cy="203200"/>
             </a:xfrm>
             <a:prstGeom prst="rect">
@@ -6664,7 +6667,7 @@
           </p:nvSpPr>
           <p:spPr>
             <a:xfrm>
-              <a:off x="9144000" y="6654800"/>
+              <a:off x="9550400" y="6654800"/>
               <a:ext cx="203200" cy="203200"/>
             </a:xfrm>
             <a:prstGeom prst="rect">
@@ -6694,7 +6697,7 @@
           </p:nvSpPr>
           <p:spPr>
             <a:xfrm>
-              <a:off x="9550400" y="6654800"/>
+              <a:off x="9956800" y="6654800"/>
               <a:ext cx="203200" cy="203200"/>
             </a:xfrm>
             <a:prstGeom prst="rect">
@@ -6724,7 +6727,7 @@
           </p:nvSpPr>
           <p:spPr>
             <a:xfrm>
-              <a:off x="9956800" y="6654800"/>
+              <a:off x="10363200" y="6654800"/>
               <a:ext cx="203200" cy="203200"/>
             </a:xfrm>
             <a:prstGeom prst="rect">
@@ -6754,7 +6757,7 @@
           </p:nvSpPr>
           <p:spPr>
             <a:xfrm>
-              <a:off x="10363200" y="6654800"/>
+              <a:off x="10769600" y="6654800"/>
               <a:ext cx="203200" cy="203200"/>
             </a:xfrm>
             <a:prstGeom prst="rect">
@@ -6784,7 +6787,7 @@
           </p:nvSpPr>
           <p:spPr>
             <a:xfrm>
-              <a:off x="10769600" y="6654800"/>
+              <a:off x="11176000" y="6654800"/>
               <a:ext cx="203200" cy="203200"/>
             </a:xfrm>
             <a:prstGeom prst="rect">
@@ -6814,7 +6817,7 @@
           </p:nvSpPr>
           <p:spPr>
             <a:xfrm>
-              <a:off x="11176000" y="6654800"/>
+              <a:off x="11582400" y="6654800"/>
               <a:ext cx="203200" cy="203200"/>
             </a:xfrm>
             <a:prstGeom prst="rect">
@@ -6839,36 +6842,6 @@
         <p:sp>
           <p:nvSpPr>
             <p:cNvPr id="64" name="Rectangle 63"/>
-            <p:cNvSpPr/>
-            <p:nvPr/>
-          </p:nvSpPr>
-          <p:spPr>
-            <a:xfrm>
-              <a:off x="11582400" y="6654800"/>
-              <a:ext cx="203200" cy="203200"/>
-            </a:xfrm>
-            <a:prstGeom prst="rect">
-              <a:avLst/>
-            </a:prstGeom>
-            <a:solidFill>
-              <a:srgbClr val="ED1C24"/>
-            </a:solidFill>
-            <a:ln>
-              <a:noFill/>
-            </a:ln>
-            <a:effectLst/>
-          </p:spPr>
-          <p:txBody>
-            <a:bodyPr rtlCol="0" anchor="ctr"/>
-            <a:lstStyle/>
-            <a:p>
-              <a:pPr algn="ctr"/>
-            </a:p>
-          </p:txBody>
-        </p:sp>
-        <p:sp>
-          <p:nvSpPr>
-            <p:cNvPr id="65" name="Rectangle 64"/>
             <p:cNvSpPr/>
             <p:nvPr/>
           </p:nvSpPr>
@@ -8858,7 +8831,7 @@
         </p:nvPicPr>
         <p:blipFill>
           <a:blip r:embed="rId2"/>
-          <a:srcRect t="8831" b="8831"/>
+          <a:srcRect l="16808" r="6808" t="12000" b="8000"/>
           <a:stretch>
             <a:fillRect/>
           </a:stretch>
@@ -10837,7 +10810,7 @@
         </p:nvPicPr>
         <p:blipFill>
           <a:blip r:embed="rId2"/>
-          <a:srcRect l="16000" r="12000" t="30805" b="14805"/>
+          <a:srcRect l="21543" r="17543" t="10000"/>
           <a:stretch>
             <a:fillRect/>
           </a:stretch>
@@ -10845,50 +10818,18 @@
         <p:spPr>
           <a:xfrm>
             <a:off x="457200" y="411480"/>
-            <a:ext cx="4846320" cy="2745740"/>
+            <a:ext cx="5120640" cy="5674360"/>
           </a:xfrm>
           <a:prstGeom prst="roundRect">
             <a:avLst>
-              <a:gd name="adj" fmla="val 4662"/>
+              <a:gd name="adj" fmla="val 2500"/>
             </a:avLst>
           </a:prstGeom>
         </p:spPr>
       </p:pic>
-      <p:sp>
-        <p:nvSpPr>
-          <p:cNvPr id="3" name="Map panel"/>
-          <p:cNvSpPr/>
-          <p:nvPr/>
-        </p:nvSpPr>
-        <p:spPr>
-          <a:xfrm>
-            <a:off x="457200" y="3340100"/>
-            <a:ext cx="4846320" cy="2745740"/>
-          </a:xfrm>
-          <a:prstGeom prst="roundRect">
-            <a:avLst>
-              <a:gd name="adj" fmla="val 4662"/>
-            </a:avLst>
-          </a:prstGeom>
-          <a:solidFill>
-            <a:srgbClr val="1E1E1E"/>
-          </a:solidFill>
-          <a:ln>
-            <a:noFill/>
-          </a:ln>
-          <a:effectLst/>
-        </p:spPr>
-        <p:txBody>
-          <a:bodyPr rtlCol="0" anchor="ctr"/>
-          <a:lstStyle/>
-          <a:p>
-            <a:pPr algn="ctr"/>
-          </a:p>
-        </p:txBody>
-      </p:sp>
       <p:pic>
         <p:nvPicPr>
-          <p:cNvPr id="4" name="Photo five_guys_world_map" descr="World map with the countries that have Five Guys restaurants in red"/>
+          <p:cNvPr id="3" name="Photo cajun_fries" descr="Five Guys Cajun fries in a white cup"/>
           <p:cNvPicPr>
             <a:picLocks noChangeAspect="1"/>
           </p:cNvPicPr>
@@ -10896,39 +10837,15 @@
         </p:nvPicPr>
         <p:blipFill>
           <a:blip r:embed="rId3"/>
+          <a:srcRect l="12417" r="28417"/>
           <a:stretch>
             <a:fillRect/>
           </a:stretch>
         </p:blipFill>
         <p:spPr>
           <a:xfrm>
-            <a:off x="640080" y="3575328"/>
-            <a:ext cx="4480560" cy="2275284"/>
-          </a:xfrm>
-          <a:prstGeom prst="rect">
-            <a:avLst/>
-          </a:prstGeom>
-        </p:spPr>
-      </p:pic>
-      <p:pic>
-        <p:nvPicPr>
-          <p:cNvPr id="5" name="Photo cajun_fries" descr="Five Guys Cajun fries in a white cup"/>
-          <p:cNvPicPr>
-            <a:picLocks noChangeAspect="1"/>
-          </p:cNvPicPr>
-          <p:nvPr/>
-        </p:nvPicPr>
-        <p:blipFill>
-          <a:blip r:embed="rId4"/>
-          <a:srcRect l="11058" r="27058"/>
-          <a:stretch>
-            <a:fillRect/>
-          </a:stretch>
-        </p:blipFill>
-        <p:spPr>
-          <a:xfrm>
-            <a:off x="5486400" y="411480"/>
-            <a:ext cx="6248400" cy="5674360"/>
+            <a:off x="5760720" y="411480"/>
+            <a:ext cx="5974080" cy="5674360"/>
           </a:xfrm>
           <a:prstGeom prst="roundRect">
             <a:avLst>
@@ -10939,7 +10856,7 @@
       </p:pic>
       <p:grpSp>
         <p:nvGrpSpPr>
-          <p:cNvPr id="6" name="Checker band"/>
+          <p:cNvPr id="4" name="Checker band"/>
           <p:cNvGrpSpPr/>
           <p:nvPr/>
         </p:nvGrpSpPr>
@@ -10953,7 +10870,7 @@
         </p:grpSpPr>
         <p:sp>
           <p:nvSpPr>
-            <p:cNvPr id="7" name="Rectangle 6"/>
+            <p:cNvPr id="5" name="Rectangle 4"/>
             <p:cNvSpPr/>
             <p:nvPr/>
           </p:nvSpPr>
@@ -10983,13 +10900,73 @@
         </p:sp>
         <p:sp>
           <p:nvSpPr>
+            <p:cNvPr id="6" name="Rectangle 5"/>
+            <p:cNvSpPr/>
+            <p:nvPr/>
+          </p:nvSpPr>
+          <p:spPr>
+            <a:xfrm>
+              <a:off x="0" y="6451600"/>
+              <a:ext cx="203200" cy="203200"/>
+            </a:xfrm>
+            <a:prstGeom prst="rect">
+              <a:avLst/>
+            </a:prstGeom>
+            <a:solidFill>
+              <a:srgbClr val="ED1C24"/>
+            </a:solidFill>
+            <a:ln>
+              <a:noFill/>
+            </a:ln>
+            <a:effectLst/>
+          </p:spPr>
+          <p:txBody>
+            <a:bodyPr rtlCol="0" anchor="ctr"/>
+            <a:lstStyle/>
+            <a:p>
+              <a:pPr algn="ctr"/>
+            </a:p>
+          </p:txBody>
+        </p:sp>
+        <p:sp>
+          <p:nvSpPr>
+            <p:cNvPr id="7" name="Rectangle 6"/>
+            <p:cNvSpPr/>
+            <p:nvPr/>
+          </p:nvSpPr>
+          <p:spPr>
+            <a:xfrm>
+              <a:off x="406400" y="6451600"/>
+              <a:ext cx="203200" cy="203200"/>
+            </a:xfrm>
+            <a:prstGeom prst="rect">
+              <a:avLst/>
+            </a:prstGeom>
+            <a:solidFill>
+              <a:srgbClr val="ED1C24"/>
+            </a:solidFill>
+            <a:ln>
+              <a:noFill/>
+            </a:ln>
+            <a:effectLst/>
+          </p:spPr>
+          <p:txBody>
+            <a:bodyPr rtlCol="0" anchor="ctr"/>
+            <a:lstStyle/>
+            <a:p>
+              <a:pPr algn="ctr"/>
+            </a:p>
+          </p:txBody>
+        </p:sp>
+        <p:sp>
+          <p:nvSpPr>
             <p:cNvPr id="8" name="Rectangle 7"/>
             <p:cNvSpPr/>
             <p:nvPr/>
           </p:nvSpPr>
           <p:spPr>
             <a:xfrm>
-              <a:off x="0" y="6451600"/>
+              <a:off x="812800" y="6451600"/>
               <a:ext cx="203200" cy="203200"/>
             </a:xfrm>
             <a:prstGeom prst="rect">
@@ -11019,7 +10996,7 @@
           </p:nvSpPr>
           <p:spPr>
             <a:xfrm>
-              <a:off x="406400" y="6451600"/>
+              <a:off x="1219200" y="6451600"/>
               <a:ext cx="203200" cy="203200"/>
             </a:xfrm>
             <a:prstGeom prst="rect">
@@ -11049,7 +11026,7 @@
           </p:nvSpPr>
           <p:spPr>
             <a:xfrm>
-              <a:off x="812800" y="6451600"/>
+              <a:off x="1625600" y="6451600"/>
               <a:ext cx="203200" cy="203200"/>
             </a:xfrm>
             <a:prstGeom prst="rect">
@@ -11079,7 +11056,7 @@
           </p:nvSpPr>
           <p:spPr>
             <a:xfrm>
-              <a:off x="1219200" y="6451600"/>
+              <a:off x="2032000" y="6451600"/>
               <a:ext cx="203200" cy="203200"/>
             </a:xfrm>
             <a:prstGeom prst="rect">
@@ -11109,7 +11086,7 @@
           </p:nvSpPr>
           <p:spPr>
             <a:xfrm>
-              <a:off x="1625600" y="6451600"/>
+              <a:off x="2438400" y="6451600"/>
               <a:ext cx="203200" cy="203200"/>
             </a:xfrm>
             <a:prstGeom prst="rect">
@@ -11139,7 +11116,7 @@
           </p:nvSpPr>
           <p:spPr>
             <a:xfrm>
-              <a:off x="2032000" y="6451600"/>
+              <a:off x="2844800" y="6451600"/>
               <a:ext cx="203200" cy="203200"/>
             </a:xfrm>
             <a:prstGeom prst="rect">
@@ -11169,7 +11146,7 @@
           </p:nvSpPr>
           <p:spPr>
             <a:xfrm>
-              <a:off x="2438400" y="6451600"/>
+              <a:off x="3251200" y="6451600"/>
               <a:ext cx="203200" cy="203200"/>
             </a:xfrm>
             <a:prstGeom prst="rect">
@@ -11199,7 +11176,7 @@
           </p:nvSpPr>
           <p:spPr>
             <a:xfrm>
-              <a:off x="2844800" y="6451600"/>
+              <a:off x="3657600" y="6451600"/>
               <a:ext cx="203200" cy="203200"/>
             </a:xfrm>
             <a:prstGeom prst="rect">
@@ -11229,7 +11206,7 @@
           </p:nvSpPr>
           <p:spPr>
             <a:xfrm>
-              <a:off x="3251200" y="6451600"/>
+              <a:off x="4064000" y="6451600"/>
               <a:ext cx="203200" cy="203200"/>
             </a:xfrm>
             <a:prstGeom prst="rect">
@@ -11259,7 +11236,7 @@
           </p:nvSpPr>
           <p:spPr>
             <a:xfrm>
-              <a:off x="3657600" y="6451600"/>
+              <a:off x="4470400" y="6451600"/>
               <a:ext cx="203200" cy="203200"/>
             </a:xfrm>
             <a:prstGeom prst="rect">
@@ -11289,7 +11266,7 @@
           </p:nvSpPr>
           <p:spPr>
             <a:xfrm>
-              <a:off x="4064000" y="6451600"/>
+              <a:off x="4876800" y="6451600"/>
               <a:ext cx="203200" cy="203200"/>
             </a:xfrm>
             <a:prstGeom prst="rect">
@@ -11319,7 +11296,7 @@
           </p:nvSpPr>
           <p:spPr>
             <a:xfrm>
-              <a:off x="4470400" y="6451600"/>
+              <a:off x="5283200" y="6451600"/>
               <a:ext cx="203200" cy="203200"/>
             </a:xfrm>
             <a:prstGeom prst="rect">
@@ -11349,7 +11326,7 @@
           </p:nvSpPr>
           <p:spPr>
             <a:xfrm>
-              <a:off x="4876800" y="6451600"/>
+              <a:off x="5689600" y="6451600"/>
               <a:ext cx="203200" cy="203200"/>
             </a:xfrm>
             <a:prstGeom prst="rect">
@@ -11379,7 +11356,7 @@
           </p:nvSpPr>
           <p:spPr>
             <a:xfrm>
-              <a:off x="5283200" y="6451600"/>
+              <a:off x="6096000" y="6451600"/>
               <a:ext cx="203200" cy="203200"/>
             </a:xfrm>
             <a:prstGeom prst="rect">
@@ -11409,7 +11386,7 @@
           </p:nvSpPr>
           <p:spPr>
             <a:xfrm>
-              <a:off x="5689600" y="6451600"/>
+              <a:off x="6502400" y="6451600"/>
               <a:ext cx="203200" cy="203200"/>
             </a:xfrm>
             <a:prstGeom prst="rect">
@@ -11439,7 +11416,7 @@
           </p:nvSpPr>
           <p:spPr>
             <a:xfrm>
-              <a:off x="6096000" y="6451600"/>
+              <a:off x="6908800" y="6451600"/>
               <a:ext cx="203200" cy="203200"/>
             </a:xfrm>
             <a:prstGeom prst="rect">
@@ -11469,7 +11446,7 @@
           </p:nvSpPr>
           <p:spPr>
             <a:xfrm>
-              <a:off x="6502400" y="6451600"/>
+              <a:off x="7315200" y="6451600"/>
               <a:ext cx="203200" cy="203200"/>
             </a:xfrm>
             <a:prstGeom prst="rect">
@@ -11499,7 +11476,7 @@
           </p:nvSpPr>
           <p:spPr>
             <a:xfrm>
-              <a:off x="6908800" y="6451600"/>
+              <a:off x="7721600" y="6451600"/>
               <a:ext cx="203200" cy="203200"/>
             </a:xfrm>
             <a:prstGeom prst="rect">
@@ -11529,7 +11506,7 @@
           </p:nvSpPr>
           <p:spPr>
             <a:xfrm>
-              <a:off x="7315200" y="6451600"/>
+              <a:off x="8128000" y="6451600"/>
               <a:ext cx="203200" cy="203200"/>
             </a:xfrm>
             <a:prstGeom prst="rect">
@@ -11559,7 +11536,7 @@
           </p:nvSpPr>
           <p:spPr>
             <a:xfrm>
-              <a:off x="7721600" y="6451600"/>
+              <a:off x="8534400" y="6451600"/>
               <a:ext cx="203200" cy="203200"/>
             </a:xfrm>
             <a:prstGeom prst="rect">
@@ -11589,7 +11566,7 @@
           </p:nvSpPr>
           <p:spPr>
             <a:xfrm>
-              <a:off x="8128000" y="6451600"/>
+              <a:off x="8940800" y="6451600"/>
               <a:ext cx="203200" cy="203200"/>
             </a:xfrm>
             <a:prstGeom prst="rect">
@@ -11619,7 +11596,7 @@
           </p:nvSpPr>
           <p:spPr>
             <a:xfrm>
-              <a:off x="8534400" y="6451600"/>
+              <a:off x="9347200" y="6451600"/>
               <a:ext cx="203200" cy="203200"/>
             </a:xfrm>
             <a:prstGeom prst="rect">
@@ -11649,7 +11626,7 @@
           </p:nvSpPr>
           <p:spPr>
             <a:xfrm>
-              <a:off x="8940800" y="6451600"/>
+              <a:off x="9753600" y="6451600"/>
               <a:ext cx="203200" cy="203200"/>
             </a:xfrm>
             <a:prstGeom prst="rect">
@@ -11679,7 +11656,7 @@
           </p:nvSpPr>
           <p:spPr>
             <a:xfrm>
-              <a:off x="9347200" y="6451600"/>
+              <a:off x="10160000" y="6451600"/>
               <a:ext cx="203200" cy="203200"/>
             </a:xfrm>
             <a:prstGeom prst="rect">
@@ -11709,7 +11686,7 @@
           </p:nvSpPr>
           <p:spPr>
             <a:xfrm>
-              <a:off x="9753600" y="6451600"/>
+              <a:off x="10566400" y="6451600"/>
               <a:ext cx="203200" cy="203200"/>
             </a:xfrm>
             <a:prstGeom prst="rect">
@@ -11739,7 +11716,7 @@
           </p:nvSpPr>
           <p:spPr>
             <a:xfrm>
-              <a:off x="10160000" y="6451600"/>
+              <a:off x="10972800" y="6451600"/>
               <a:ext cx="203200" cy="203200"/>
             </a:xfrm>
             <a:prstGeom prst="rect">
@@ -11769,7 +11746,7 @@
           </p:nvSpPr>
           <p:spPr>
             <a:xfrm>
-              <a:off x="10566400" y="6451600"/>
+              <a:off x="11379200" y="6451600"/>
               <a:ext cx="203200" cy="203200"/>
             </a:xfrm>
             <a:prstGeom prst="rect">
@@ -11799,7 +11776,7 @@
           </p:nvSpPr>
           <p:spPr>
             <a:xfrm>
-              <a:off x="10972800" y="6451600"/>
+              <a:off x="11785600" y="6451600"/>
               <a:ext cx="203200" cy="203200"/>
             </a:xfrm>
             <a:prstGeom prst="rect">
@@ -11829,7 +11806,7 @@
           </p:nvSpPr>
           <p:spPr>
             <a:xfrm>
-              <a:off x="11379200" y="6451600"/>
+              <a:off x="203200" y="6654800"/>
               <a:ext cx="203200" cy="203200"/>
             </a:xfrm>
             <a:prstGeom prst="rect">
@@ -11859,7 +11836,7 @@
           </p:nvSpPr>
           <p:spPr>
             <a:xfrm>
-              <a:off x="11785600" y="6451600"/>
+              <a:off x="609600" y="6654800"/>
               <a:ext cx="203200" cy="203200"/>
             </a:xfrm>
             <a:prstGeom prst="rect">
@@ -11889,7 +11866,7 @@
           </p:nvSpPr>
           <p:spPr>
             <a:xfrm>
-              <a:off x="203200" y="6654800"/>
+              <a:off x="1016000" y="6654800"/>
               <a:ext cx="203200" cy="203200"/>
             </a:xfrm>
             <a:prstGeom prst="rect">
@@ -11919,7 +11896,7 @@
           </p:nvSpPr>
           <p:spPr>
             <a:xfrm>
-              <a:off x="609600" y="6654800"/>
+              <a:off x="1422400" y="6654800"/>
               <a:ext cx="203200" cy="203200"/>
             </a:xfrm>
             <a:prstGeom prst="rect">
@@ -11949,7 +11926,7 @@
           </p:nvSpPr>
           <p:spPr>
             <a:xfrm>
-              <a:off x="1016000" y="6654800"/>
+              <a:off x="1828800" y="6654800"/>
               <a:ext cx="203200" cy="203200"/>
             </a:xfrm>
             <a:prstGeom prst="rect">
@@ -11979,7 +11956,7 @@
           </p:nvSpPr>
           <p:spPr>
             <a:xfrm>
-              <a:off x="1422400" y="6654800"/>
+              <a:off x="2235200" y="6654800"/>
               <a:ext cx="203200" cy="203200"/>
             </a:xfrm>
             <a:prstGeom prst="rect">
@@ -12009,7 +11986,7 @@
           </p:nvSpPr>
           <p:spPr>
             <a:xfrm>
-              <a:off x="1828800" y="6654800"/>
+              <a:off x="2641600" y="6654800"/>
               <a:ext cx="203200" cy="203200"/>
             </a:xfrm>
             <a:prstGeom prst="rect">
@@ -12039,7 +12016,7 @@
           </p:nvSpPr>
           <p:spPr>
             <a:xfrm>
-              <a:off x="2235200" y="6654800"/>
+              <a:off x="3048000" y="6654800"/>
               <a:ext cx="203200" cy="203200"/>
             </a:xfrm>
             <a:prstGeom prst="rect">
@@ -12069,7 +12046,7 @@
           </p:nvSpPr>
           <p:spPr>
             <a:xfrm>
-              <a:off x="2641600" y="6654800"/>
+              <a:off x="3454400" y="6654800"/>
               <a:ext cx="203200" cy="203200"/>
             </a:xfrm>
             <a:prstGeom prst="rect">
@@ -12099,7 +12076,7 @@
           </p:nvSpPr>
           <p:spPr>
             <a:xfrm>
-              <a:off x="3048000" y="6654800"/>
+              <a:off x="3860800" y="6654800"/>
               <a:ext cx="203200" cy="203200"/>
             </a:xfrm>
             <a:prstGeom prst="rect">
@@ -12129,7 +12106,7 @@
           </p:nvSpPr>
           <p:spPr>
             <a:xfrm>
-              <a:off x="3454400" y="6654800"/>
+              <a:off x="4267200" y="6654800"/>
               <a:ext cx="203200" cy="203200"/>
             </a:xfrm>
             <a:prstGeom prst="rect">
@@ -12159,7 +12136,7 @@
           </p:nvSpPr>
           <p:spPr>
             <a:xfrm>
-              <a:off x="3860800" y="6654800"/>
+              <a:off x="4673600" y="6654800"/>
               <a:ext cx="203200" cy="203200"/>
             </a:xfrm>
             <a:prstGeom prst="rect">
@@ -12189,7 +12166,7 @@
           </p:nvSpPr>
           <p:spPr>
             <a:xfrm>
-              <a:off x="4267200" y="6654800"/>
+              <a:off x="5080000" y="6654800"/>
               <a:ext cx="203200" cy="203200"/>
             </a:xfrm>
             <a:prstGeom prst="rect">
@@ -12219,7 +12196,7 @@
           </p:nvSpPr>
           <p:spPr>
             <a:xfrm>
-              <a:off x="4673600" y="6654800"/>
+              <a:off x="5486400" y="6654800"/>
               <a:ext cx="203200" cy="203200"/>
             </a:xfrm>
             <a:prstGeom prst="rect">
@@ -12249,7 +12226,7 @@
           </p:nvSpPr>
           <p:spPr>
             <a:xfrm>
-              <a:off x="5080000" y="6654800"/>
+              <a:off x="5892800" y="6654800"/>
               <a:ext cx="203200" cy="203200"/>
             </a:xfrm>
             <a:prstGeom prst="rect">
@@ -12279,7 +12256,7 @@
           </p:nvSpPr>
           <p:spPr>
             <a:xfrm>
-              <a:off x="5486400" y="6654800"/>
+              <a:off x="6299200" y="6654800"/>
               <a:ext cx="203200" cy="203200"/>
             </a:xfrm>
             <a:prstGeom prst="rect">
@@ -12309,7 +12286,7 @@
           </p:nvSpPr>
           <p:spPr>
             <a:xfrm>
-              <a:off x="5892800" y="6654800"/>
+              <a:off x="6705600" y="6654800"/>
               <a:ext cx="203200" cy="203200"/>
             </a:xfrm>
             <a:prstGeom prst="rect">
@@ -12339,7 +12316,7 @@
           </p:nvSpPr>
           <p:spPr>
             <a:xfrm>
-              <a:off x="6299200" y="6654800"/>
+              <a:off x="7112000" y="6654800"/>
               <a:ext cx="203200" cy="203200"/>
             </a:xfrm>
             <a:prstGeom prst="rect">
@@ -12369,7 +12346,7 @@
           </p:nvSpPr>
           <p:spPr>
             <a:xfrm>
-              <a:off x="6705600" y="6654800"/>
+              <a:off x="7518400" y="6654800"/>
               <a:ext cx="203200" cy="203200"/>
             </a:xfrm>
             <a:prstGeom prst="rect">
@@ -12399,7 +12376,7 @@
           </p:nvSpPr>
           <p:spPr>
             <a:xfrm>
-              <a:off x="7112000" y="6654800"/>
+              <a:off x="7924800" y="6654800"/>
               <a:ext cx="203200" cy="203200"/>
             </a:xfrm>
             <a:prstGeom prst="rect">
@@ -12429,7 +12406,7 @@
           </p:nvSpPr>
           <p:spPr>
             <a:xfrm>
-              <a:off x="7518400" y="6654800"/>
+              <a:off x="8331200" y="6654800"/>
               <a:ext cx="203200" cy="203200"/>
             </a:xfrm>
             <a:prstGeom prst="rect">
@@ -12459,7 +12436,7 @@
           </p:nvSpPr>
           <p:spPr>
             <a:xfrm>
-              <a:off x="7924800" y="6654800"/>
+              <a:off x="8737600" y="6654800"/>
               <a:ext cx="203200" cy="203200"/>
             </a:xfrm>
             <a:prstGeom prst="rect">
@@ -12489,7 +12466,7 @@
           </p:nvSpPr>
           <p:spPr>
             <a:xfrm>
-              <a:off x="8331200" y="6654800"/>
+              <a:off x="9144000" y="6654800"/>
               <a:ext cx="203200" cy="203200"/>
             </a:xfrm>
             <a:prstGeom prst="rect">
@@ -12519,7 +12496,7 @@
           </p:nvSpPr>
           <p:spPr>
             <a:xfrm>
-              <a:off x="8737600" y="6654800"/>
+              <a:off x="9550400" y="6654800"/>
               <a:ext cx="203200" cy="203200"/>
             </a:xfrm>
             <a:prstGeom prst="rect">
@@ -12549,7 +12526,7 @@
           </p:nvSpPr>
           <p:spPr>
             <a:xfrm>
-              <a:off x="9144000" y="6654800"/>
+              <a:off x="9956800" y="6654800"/>
               <a:ext cx="203200" cy="203200"/>
             </a:xfrm>
             <a:prstGeom prst="rect">
@@ -12579,7 +12556,7 @@
           </p:nvSpPr>
           <p:spPr>
             <a:xfrm>
-              <a:off x="9550400" y="6654800"/>
+              <a:off x="10363200" y="6654800"/>
               <a:ext cx="203200" cy="203200"/>
             </a:xfrm>
             <a:prstGeom prst="rect">
@@ -12609,7 +12586,7 @@
           </p:nvSpPr>
           <p:spPr>
             <a:xfrm>
-              <a:off x="9956800" y="6654800"/>
+              <a:off x="10769600" y="6654800"/>
               <a:ext cx="203200" cy="203200"/>
             </a:xfrm>
             <a:prstGeom prst="rect">
@@ -12639,7 +12616,7 @@
           </p:nvSpPr>
           <p:spPr>
             <a:xfrm>
-              <a:off x="10363200" y="6654800"/>
+              <a:off x="11176000" y="6654800"/>
               <a:ext cx="203200" cy="203200"/>
             </a:xfrm>
             <a:prstGeom prst="rect">
@@ -12669,7 +12646,7 @@
           </p:nvSpPr>
           <p:spPr>
             <a:xfrm>
-              <a:off x="10769600" y="6654800"/>
+              <a:off x="11582400" y="6654800"/>
               <a:ext cx="203200" cy="203200"/>
             </a:xfrm>
             <a:prstGeom prst="rect">
@@ -12694,66 +12671,6 @@
         <p:sp>
           <p:nvSpPr>
             <p:cNvPr id="65" name="Rectangle 64"/>
-            <p:cNvSpPr/>
-            <p:nvPr/>
-          </p:nvSpPr>
-          <p:spPr>
-            <a:xfrm>
-              <a:off x="11176000" y="6654800"/>
-              <a:ext cx="203200" cy="203200"/>
-            </a:xfrm>
-            <a:prstGeom prst="rect">
-              <a:avLst/>
-            </a:prstGeom>
-            <a:solidFill>
-              <a:srgbClr val="ED1C24"/>
-            </a:solidFill>
-            <a:ln>
-              <a:noFill/>
-            </a:ln>
-            <a:effectLst/>
-          </p:spPr>
-          <p:txBody>
-            <a:bodyPr rtlCol="0" anchor="ctr"/>
-            <a:lstStyle/>
-            <a:p>
-              <a:pPr algn="ctr"/>
-            </a:p>
-          </p:txBody>
-        </p:sp>
-        <p:sp>
-          <p:nvSpPr>
-            <p:cNvPr id="66" name="Rectangle 65"/>
-            <p:cNvSpPr/>
-            <p:nvPr/>
-          </p:nvSpPr>
-          <p:spPr>
-            <a:xfrm>
-              <a:off x="11582400" y="6654800"/>
-              <a:ext cx="203200" cy="203200"/>
-            </a:xfrm>
-            <a:prstGeom prst="rect">
-              <a:avLst/>
-            </a:prstGeom>
-            <a:solidFill>
-              <a:srgbClr val="ED1C24"/>
-            </a:solidFill>
-            <a:ln>
-              <a:noFill/>
-            </a:ln>
-            <a:effectLst/>
-          </p:spPr>
-          <p:txBody>
-            <a:bodyPr rtlCol="0" anchor="ctr"/>
-            <a:lstStyle/>
-            <a:p>
-              <a:pPr algn="ctr"/>
-            </a:p>
-          </p:txBody>
-        </p:sp>
-        <p:sp>
-          <p:nvSpPr>
-            <p:cNvPr id="67" name="Rectangle 66"/>
             <p:cNvSpPr/>
             <p:nvPr/>
           </p:nvSpPr>

</xml_diff>